<commit_message>
Update ICIC 2026 presentation slides
</commit_message>
<xml_diff>
--- a/draft-icic-2026/057_MUTTAQIN.pptx
+++ b/draft-icic-2026/057_MUTTAQIN.pptx
@@ -2079,7 +2079,7 @@
           <a:p>
             <a:r>
               <a:rPr lang="en-US" dirty="0"/>
-              <a:t>Good morning. I will present a benchmark of multi-view, tree-level oil palm bunch counting, and the main question: when counting fails, is it the counter or the detector?</a:t>
+              <a:t>[0:30] Good morning, everyone. My name is Muhammad Zainal Muttaqin, from Lambung Mangkurat University, Indonesia. Today I will present our work: Benchmarking Multi-View Tree-Level Oil Palm Bunch Counting Under a Fixed Detector. The whole talk revolves around one simple question: when automatic bunch counting fails, is the problem the counter, or the detector?</a:t>
             </a:r>
             <a:endParaRPr lang="en-US" dirty="0"/>
           </a:p>
@@ -2167,7 +2167,7 @@
           <a:p>
             <a:r>
               <a:rPr lang="en-US" dirty="0"/>
-              <a:t/>
+              <a:t>[0:15] Thank you for your attention. Our code and results are publicly available on GitHub. I am happy to take your questions.</a:t>
             </a:r>
             <a:endParaRPr lang="en-US" dirty="0"/>
           </a:p>
@@ -2255,7 +2255,9 @@
           <a:p>
             <a:r>
               <a:rPr lang="en-US" dirty="0"/>
-              <a:t>Harvest planning depends on the BBC: how many bunches per tree in each class B1 to B4. Bunches surround the trunk, so we photograph each tree from 4 to 8 sides. But the same bunch appears in multiple images, so naive summation overcounts.</a:t>
+              <a:t>[1:15] Oil palm plantations plan their harvest using the Black Bunch Census. For every tree, workers count how many bunches belong to each maturity class, from B1 to B4. Doing this manually is slow and subjective, so we want to automate it with images.
+But there is a challenge. Bunches grow all around the trunk and are often hidden behind fronds. So we photograph each tree from four to eight sides. Look at these three views: the highlighted bunch is the same B3 bunch, seen three times. If we simply add up the detections, we count it three times. The census needs it counted only once.
+So the open question is: where does counting error really come from — from the counting model, or from the detector that feeds it?</a:t>
             </a:r>
             <a:endParaRPr lang="en-US" dirty="0"/>
           </a:p>
@@ -2343,7 +2345,9 @@
           <a:p>
             <a:r>
               <a:rPr lang="en-US" dirty="0"/>
-              <a:t>SawitMVC has 953 trees and 3,992 images from two South Kalimantan estates. Each tree gives detections, either ground truth or from a frozen YOLO26m, which are summarized into tree-level feature vectors and mapped by a regressor to four class counts. Comparing both input conditions separates counter quality from detector quality.</a:t>
+              <a:t>[1:00] We work with SawitMVC: 953 trees, 3,992 images, and four maturity classes, with a fixed split of 716 training, 96 validation and 141 test trees.
+The pipeline has five steps. We take the multi-view images, obtain detections, summarize them into tree-level feature vectors, from a 13-dimensional baseline F0 up to 67 dimensions, and a regression model predicts the four class counts.
+The key design of this study is here: we fit the same counters twice — once on ground-truth boxes, and once on outputs from a frozen YOLO26m detector. The difference between these two conditions tells us how much input quality matters.</a:t>
             </a:r>
             <a:endParaRPr lang="en-US" dirty="0"/>
           </a:p>
@@ -2431,7 +2435,8 @@
           <a:p>
             <a:r>
               <a:rPr lang="en-US" dirty="0"/>
-              <a:t>Class ±1 checks each maturity class separately. Tree ±1 is stricter: all four counts must be within one bunch simultaneously, which is what a census really needs. Statistics use tree-level bootstrap and paired permutation tests with Holm correction.</a:t>
+              <a:t>[0:50] We use two main accuracy measures. Class plus-minus one checks whether each class count is within one bunch of the truth. Tree plus-minus one is stricter: all four class counts must be correct within one bunch at the same time — which is what a census really needs.
+We compare two simple baselines, five regression counters and eight feature sets. To make the comparisons fair, we use bootstrap confidence intervals, paired permutation tests with Holm correction, and several sensitivity checks.</a:t>
             </a:r>
             <a:endParaRPr lang="en-US" dirty="0"/>
           </a:p>
@@ -2519,7 +2524,9 @@
           <a:p>
             <a:r>
               <a:rPr lang="en-US" dirty="0"/>
-              <a:t>Naive summation fails in both conditions. A calibrated divisor recovers much, and regressors improve further. Under GT inputs all linear counters are near 98%. With the detector, all counters drop to 73–76%, and their differences are not statistically significant. The drop between conditions is much larger than the differences between counters.</a:t>
+              <a:t>[1:15] Here is the first main result. The green bars use ground-truth detections, the orange bars use the detector.
+First, naive summation fails in both conditions, at around fifty percent. Second, with ground-truth inputs, all the linear counters reach about ninety-eight percent. But when we switch to detector inputs, every counter drops to between seventy-three and seventy-six percent.
+The spread among the five counters is only 3.19 percentage points, and no pair is statistically different after correction. In contrast, the same counter loses about 21.6 points just by changing the input. So the choice of counter matters little; the quality of the input matters a lot.</a:t>
             </a:r>
             <a:endParaRPr lang="en-US" dirty="0"/>
           </a:p>
@@ -2607,7 +2614,9 @@
           <a:p>
             <a:r>
               <a:rPr lang="en-US" dirty="0"/>
-              <a:t>The best GT configuration reaches 98.05% class accuracy; the best detector configuration reaches 77.48%, a gap of 20.57 points. At tree level, the gap is almost 60 points. B3 and B4 lose the most. Adding 54 extra features to Ridge changes class accuracy by only 1.42 points, not significant.</a:t>
+              <a:t>[1:10] Looking at the best configurations, class accuracy falls from 98.05 to 77.48 percent — a gap of 20.57 points, with a confidence interval from 17 to 24. At tree level the drop is dramatic: from 92.2 to 32.6 percent.
+The chart on the right shows where it happens. B1 is almost unaffected, but B3 drops to 57 percent and B4 to 72 percent.
+Could richer features fix this? Not really. Using all 67 features adds only 1.42 points over the baseline, and this gain is not statistically significant.</a:t>
             </a:r>
             <a:endParaRPr lang="en-US" dirty="0"/>
           </a:p>
@@ -2695,7 +2704,9 @@
           <a:p>
             <a:r>
               <a:rPr lang="en-US" dirty="0"/>
-              <a:t>Only 47.9% of test appearances are both detected and correctly classified. 22.7% of physical bunches are never detected in any view, so no counter can directly associate them. B2 is often confused with B3, and B4 is mostly missed. These diagnostics are not an additive error budget, but they point to detection quality.</a:t>
+              <a:t>[1:10] To understand why, we matched every detection to the annotations. Of 2,612 ground-truth appearances, only 48 percent are both found and correctly classified. 37 percent are missed, and 15 percent are found but given the wrong maturity class.
+Three numbers stand out. First, 22.7 percent of physical bunches are never detected in any view — for B4 it is 42 percent. No counter can directly count a bunch it never sees. Second, 158 B2 appearances are read as B3, so class confusion is a major error source. Third, 30 percent of detections are false positives, mostly with low confidence.
+These diagnostics are not an additive error budget, but they clearly point to detection quality.</a:t>
             </a:r>
             <a:endParaRPr lang="en-US" dirty="0"/>
           </a:p>
@@ -2783,7 +2794,8 @@
           <a:p>
             <a:r>
               <a:rPr lang="en-US" dirty="0"/>
-              <a:t>The gap holds when winners are chosen on validation data, in matched cross-validation, with a separately trained YOLO11m, and across four YOLO26 checkpoints. No detector threshold exceeds 77.48% class accuracy, far below the GT reference of 98%.</a:t>
+              <a:t>[1:00] We also checked whether this conclusion is fragile. It is not. The gap remains about 24 points when the best model is selected on validation data instead of the test set, about 25 points in matched five-by-five cross-validation, about 24 points with a separately trained YOLO11m detector, and about 23 points across four YOLO26 checkpoints.
+On the right, we varied the detector's confidence threshold from 0.05 to 0.7. No threshold exceeds 77.48 percent, still far below the ground-truth reference of 98 percent.</a:t>
             </a:r>
             <a:endParaRPr lang="en-US" dirty="0"/>
           </a:p>
@@ -2871,7 +2883,8 @@
           <a:p>
             <a:r>
               <a:rPr lang="en-US" dirty="0"/>
-              <a:t>To conclude: the GT advantage persists across counters, selection, resampling and detector families. For the census, improving B3/B4 detection and B2-to-B3 classification is the priority. Future work will compare explicit association methods and test on independent plantations.</a:t>
+              <a:t>[1:00] To conclude, three takeaways. First, on this dataset, improving detector output quality matters more than choosing a different counter. Second, for the census, the priorities are better B3 and B4 detection and less B2-to-B3 confusion. Third, we recommend evaluating counters under both ground-truth and detector inputs, and reporting class, tree and total metrics together with signed bias.
+Our study has limitations: one dataset from two estates, and ground truth is an empirical reference, not an upper bound for future methods. Next, we plan to compare explicit multi-view association with learned aggregation, and test on independent plantations.</a:t>
             </a:r>
             <a:endParaRPr lang="en-US" dirty="0"/>
           </a:p>

</xml_diff>